<commit_message>
Rewrite the slide titles in a conventional scientific register
Fourteen titles were rhetorical rather than descriptive. A section heading in a
talk should name its content, not set up a reveal: "What Is Actually Decoded"
is the artefact control, "Two Cohorts Added Last" is the result on cohorts D
and E, and "The Rate Condition, Measured by Manipulation" is a direct
manipulation of the estimator memory. Titles now say which analysis the slide
shows. No content, figure, table or number changed.

Co-Authored-By: Claude Opus 5 <noreply@anthropic.com>
</commit_message>
<xml_diff>
--- a/presentation/CALM-Net_final_presentation.pptx
+++ b/presentation/CALM-Net_final_presentation.pptx
@@ -6191,7 +6191,7 @@
                 </a:solidFill>
                 <a:latin typeface="Times New Roman"/>
               </a:rPr>
-              <a:t>Five Cohorts, One Pipeline</a:t>
+              <a:t>Datasets and Evaluation Protocol</a:t>
             </a:r>
           </a:p>
         </p:txBody>
@@ -6547,7 +6547,7 @@
                 </a:solidFill>
                 <a:latin typeface="Times New Roman"/>
               </a:rPr>
-              <a:t>What Is Actually Decoded</a:t>
+              <a:t>Artefact Control</a:t>
             </a:r>
           </a:p>
         </p:txBody>
@@ -6838,7 +6838,7 @@
                 </a:solidFill>
                 <a:latin typeface="Times New Roman"/>
               </a:rPr>
-              <a:t>Where the Reference Acts</a:t>
+              <a:t>Scalp Topography of the Reference</a:t>
             </a:r>
           </a:p>
         </p:txBody>
@@ -7063,7 +7063,7 @@
                 </a:solidFill>
                 <a:latin typeface="Times New Roman"/>
               </a:rPr>
-              <a:t>What the Model Computes</a:t>
+              <a:t>Learned Representations</a:t>
             </a:r>
           </a:p>
         </p:txBody>
@@ -7288,7 +7288,7 @@
                 </a:solidFill>
                 <a:latin typeface="Times New Roman"/>
               </a:rPr>
-              <a:t>Against Eight Published Decoders</a:t>
+              <a:t>Comparison with Published Decoders</a:t>
             </a:r>
           </a:p>
         </p:txBody>
@@ -7513,7 +7513,7 @@
                 </a:solidFill>
                 <a:latin typeface="Times New Roman"/>
               </a:rPr>
-              <a:t>The Branch Against the Stem</a:t>
+              <a:t>Branch versus Stem Across Cohorts</a:t>
             </a:r>
           </a:p>
         </p:txBody>
@@ -7738,7 +7738,7 @@
                 </a:solidFill>
                 <a:latin typeface="Times New Roman"/>
               </a:rPr>
-              <a:t>Cohort C, Held Out From Every Design Decision</a:t>
+              <a:t>Results on the Held-Out Cohort</a:t>
             </a:r>
           </a:p>
         </p:txBody>
@@ -7963,7 +7963,7 @@
                 </a:solidFill>
                 <a:latin typeface="Times New Roman"/>
               </a:rPr>
-              <a:t>The Boundary Across Five Cohorts</a:t>
+              <a:t>Effect Size Against Class-Block Length</a:t>
             </a:r>
           </a:p>
         </p:txBody>
@@ -8188,7 +8188,7 @@
                 </a:solidFill>
                 <a:latin typeface="Times New Roman"/>
               </a:rPr>
-              <a:t>The Rate Condition, Measured by Manipulation</a:t>
+              <a:t>Direct Manipulation of the Estimator Memory</a:t>
             </a:r>
           </a:p>
         </p:txBody>
@@ -8413,7 +8413,7 @@
                 </a:solidFill>
                 <a:latin typeface="Times New Roman"/>
               </a:rPr>
-              <a:t>Estimator Memory Against Block Length</a:t>
+              <a:t>Estimator Memory and Block Length: Summary</a:t>
             </a:r>
           </a:p>
         </p:txBody>
@@ -8667,7 +8667,7 @@
                 </a:solidFill>
                 <a:latin typeface="Times New Roman"/>
               </a:rPr>
-              <a:t>Ablation of the Reported Model</a:t>
+              <a:t>Ablation Study</a:t>
             </a:r>
           </a:p>
         </p:txBody>
@@ -8916,7 +8916,7 @@
                 </a:solidFill>
                 <a:latin typeface="Times New Roman"/>
               </a:rPr>
-              <a:t>Measurement Noise</a:t>
+              <a:t>Measurement Noise and Ranking Criteria</a:t>
             </a:r>
           </a:p>
         </p:txBody>
@@ -9170,7 +9170,7 @@
                 </a:solidFill>
                 <a:latin typeface="Times New Roman"/>
               </a:rPr>
-              <a:t>What the Branch Costs a Controller</a:t>
+              <a:t>Control-Relevant Outcome Measures</a:t>
             </a:r>
           </a:p>
         </p:txBody>
@@ -9424,7 +9424,7 @@
                 </a:solidFill>
                 <a:latin typeface="Times New Roman"/>
               </a:rPr>
-              <a:t>Two Cohorts Added Last</a:t>
+              <a:t>Results on Cohorts D and E</a:t>
             </a:r>
           </a:p>
         </p:txBody>

</xml_diff>